<commit_message>
Added Changes to powerpoint
</commit_message>
<xml_diff>
--- a/Mental Health Report.pptx
+++ b/Mental Health Report.pptx
@@ -5,25 +5,28 @@
     <p:sldMasterId id="2147483669" r:id="rId4"/>
   </p:sldMasterIdLst>
   <p:notesMasterIdLst>
-    <p:notesMasterId r:id="rId18"/>
+    <p:notesMasterId r:id="rId21"/>
   </p:notesMasterIdLst>
   <p:handoutMasterIdLst>
-    <p:handoutMasterId r:id="rId19"/>
+    <p:handoutMasterId r:id="rId22"/>
   </p:handoutMasterIdLst>
   <p:sldIdLst>
     <p:sldId id="256" r:id="rId5"/>
-    <p:sldId id="258" r:id="rId6"/>
-    <p:sldId id="261" r:id="rId7"/>
-    <p:sldId id="262" r:id="rId8"/>
-    <p:sldId id="264" r:id="rId9"/>
-    <p:sldId id="265" r:id="rId10"/>
-    <p:sldId id="269" r:id="rId11"/>
-    <p:sldId id="266" r:id="rId12"/>
-    <p:sldId id="268" r:id="rId13"/>
-    <p:sldId id="267" r:id="rId14"/>
-    <p:sldId id="270" r:id="rId15"/>
-    <p:sldId id="271" r:id="rId16"/>
-    <p:sldId id="272" r:id="rId17"/>
+    <p:sldId id="273" r:id="rId6"/>
+    <p:sldId id="258" r:id="rId7"/>
+    <p:sldId id="261" r:id="rId8"/>
+    <p:sldId id="262" r:id="rId9"/>
+    <p:sldId id="264" r:id="rId10"/>
+    <p:sldId id="265" r:id="rId11"/>
+    <p:sldId id="269" r:id="rId12"/>
+    <p:sldId id="266" r:id="rId13"/>
+    <p:sldId id="268" r:id="rId14"/>
+    <p:sldId id="267" r:id="rId15"/>
+    <p:sldId id="270" r:id="rId16"/>
+    <p:sldId id="271" r:id="rId17"/>
+    <p:sldId id="274" r:id="rId18"/>
+    <p:sldId id="275" r:id="rId19"/>
+    <p:sldId id="272" r:id="rId20"/>
   </p:sldIdLst>
   <p:sldSz cx="12192000" cy="6858000"/>
   <p:notesSz cx="6858000" cy="9144000"/>
@@ -227,7 +230,7 @@
           <a:p>
             <a:fld id="{2B85766F-5EC0-4797-B4D1-777FCB005B11}" type="datetimeFigureOut">
               <a:rPr lang="en-US" smtClean="0"/>
-              <a:t>8/1/2025</a:t>
+              <a:t>8/12/2025</a:t>
             </a:fld>
             <a:endParaRPr lang="en-US" dirty="0"/>
           </a:p>
@@ -404,7 +407,7 @@
           <a:p>
             <a:fld id="{B2B4B5EC-152C-4627-80C0-63B10D5574EF}" type="datetimeFigureOut">
               <a:rPr lang="en-US" smtClean="0"/>
-              <a:t>8/1/2025</a:t>
+              <a:t>8/12/2025</a:t>
             </a:fld>
             <a:endParaRPr lang="en-US" dirty="0"/>
           </a:p>
@@ -4953,7 +4956,7 @@
           <a:p>
             <a:fld id="{48A87A34-81AB-432B-8DAE-1953F412C126}" type="datetimeFigureOut">
               <a:rPr lang="en-US" smtClean="0"/>
-              <a:t>8/1/2025</a:t>
+              <a:t>8/12/2025</a:t>
             </a:fld>
             <a:endParaRPr lang="en-US" dirty="0"/>
           </a:p>
@@ -5220,7 +5223,7 @@
           <a:p>
             <a:fld id="{48A87A34-81AB-432B-8DAE-1953F412C126}" type="datetimeFigureOut">
               <a:rPr lang="en-US" smtClean="0"/>
-              <a:t>8/1/2025</a:t>
+              <a:t>8/12/2025</a:t>
             </a:fld>
             <a:endParaRPr lang="en-US" dirty="0"/>
           </a:p>
@@ -5416,7 +5419,7 @@
           <a:p>
             <a:fld id="{48A87A34-81AB-432B-8DAE-1953F412C126}" type="datetimeFigureOut">
               <a:rPr lang="en-US" smtClean="0"/>
-              <a:t>8/1/2025</a:t>
+              <a:t>8/12/2025</a:t>
             </a:fld>
             <a:endParaRPr lang="en-US" dirty="0"/>
           </a:p>
@@ -5679,7 +5682,7 @@
           <a:p>
             <a:fld id="{48A87A34-81AB-432B-8DAE-1953F412C126}" type="datetimeFigureOut">
               <a:rPr lang="en-US" smtClean="0"/>
-              <a:t>8/1/2025</a:t>
+              <a:t>8/12/2025</a:t>
             </a:fld>
             <a:endParaRPr lang="en-US" dirty="0"/>
           </a:p>
@@ -6113,7 +6116,7 @@
           <a:p>
             <a:fld id="{48A87A34-81AB-432B-8DAE-1953F412C126}" type="datetimeFigureOut">
               <a:rPr lang="en-US" smtClean="0"/>
-              <a:t>8/1/2025</a:t>
+              <a:t>8/12/2025</a:t>
             </a:fld>
             <a:endParaRPr lang="en-US" dirty="0"/>
           </a:p>
@@ -6659,7 +6662,7 @@
           <a:p>
             <a:fld id="{48A87A34-81AB-432B-8DAE-1953F412C126}" type="datetimeFigureOut">
               <a:rPr lang="en-US" smtClean="0"/>
-              <a:t>8/1/2025</a:t>
+              <a:t>8/12/2025</a:t>
             </a:fld>
             <a:endParaRPr lang="en-US" dirty="0"/>
           </a:p>
@@ -7379,7 +7382,7 @@
           <a:p>
             <a:fld id="{48A87A34-81AB-432B-8DAE-1953F412C126}" type="datetimeFigureOut">
               <a:rPr lang="en-US" smtClean="0"/>
-              <a:t>8/1/2025</a:t>
+              <a:t>8/12/2025</a:t>
             </a:fld>
             <a:endParaRPr lang="en-US" dirty="0"/>
           </a:p>
@@ -7549,7 +7552,7 @@
           <a:p>
             <a:fld id="{48A87A34-81AB-432B-8DAE-1953F412C126}" type="datetimeFigureOut">
               <a:rPr lang="en-US" smtClean="0"/>
-              <a:t>8/1/2025</a:t>
+              <a:t>8/12/2025</a:t>
             </a:fld>
             <a:endParaRPr lang="en-US" dirty="0"/>
           </a:p>
@@ -7729,7 +7732,7 @@
           <a:p>
             <a:fld id="{48A87A34-81AB-432B-8DAE-1953F412C126}" type="datetimeFigureOut">
               <a:rPr lang="en-US" smtClean="0"/>
-              <a:t>8/1/2025</a:t>
+              <a:t>8/12/2025</a:t>
             </a:fld>
             <a:endParaRPr lang="en-US" dirty="0"/>
           </a:p>
@@ -7899,7 +7902,7 @@
           <a:p>
             <a:fld id="{48A87A34-81AB-432B-8DAE-1953F412C126}" type="datetimeFigureOut">
               <a:rPr lang="en-US" smtClean="0"/>
-              <a:t>8/1/2025</a:t>
+              <a:t>8/12/2025</a:t>
             </a:fld>
             <a:endParaRPr lang="en-US" dirty="0"/>
           </a:p>
@@ -8149,7 +8152,7 @@
           <a:p>
             <a:fld id="{48A87A34-81AB-432B-8DAE-1953F412C126}" type="datetimeFigureOut">
               <a:rPr lang="en-US" smtClean="0"/>
-              <a:t>8/1/2025</a:t>
+              <a:t>8/12/2025</a:t>
             </a:fld>
             <a:endParaRPr lang="en-US" dirty="0"/>
           </a:p>
@@ -8381,7 +8384,7 @@
           <a:p>
             <a:fld id="{48A87A34-81AB-432B-8DAE-1953F412C126}" type="datetimeFigureOut">
               <a:rPr lang="en-US" smtClean="0"/>
-              <a:t>8/1/2025</a:t>
+              <a:t>8/12/2025</a:t>
             </a:fld>
             <a:endParaRPr lang="en-US" dirty="0"/>
           </a:p>
@@ -8762,7 +8765,7 @@
           <a:p>
             <a:fld id="{48A87A34-81AB-432B-8DAE-1953F412C126}" type="datetimeFigureOut">
               <a:rPr lang="en-US" smtClean="0"/>
-              <a:t>8/1/2025</a:t>
+              <a:t>8/12/2025</a:t>
             </a:fld>
             <a:endParaRPr lang="en-US" dirty="0"/>
           </a:p>
@@ -8880,7 +8883,7 @@
           <a:p>
             <a:fld id="{48A87A34-81AB-432B-8DAE-1953F412C126}" type="datetimeFigureOut">
               <a:rPr lang="en-US" smtClean="0"/>
-              <a:t>8/1/2025</a:t>
+              <a:t>8/12/2025</a:t>
             </a:fld>
             <a:endParaRPr lang="en-US" dirty="0"/>
           </a:p>
@@ -8975,7 +8978,7 @@
           <a:p>
             <a:fld id="{48A87A34-81AB-432B-8DAE-1953F412C126}" type="datetimeFigureOut">
               <a:rPr lang="en-US" smtClean="0"/>
-              <a:t>8/1/2025</a:t>
+              <a:t>8/12/2025</a:t>
             </a:fld>
             <a:endParaRPr lang="en-US" dirty="0"/>
           </a:p>
@@ -9224,7 +9227,7 @@
           <a:p>
             <a:fld id="{48A87A34-81AB-432B-8DAE-1953F412C126}" type="datetimeFigureOut">
               <a:rPr lang="en-US" smtClean="0"/>
-              <a:t>8/1/2025</a:t>
+              <a:t>8/12/2025</a:t>
             </a:fld>
             <a:endParaRPr lang="en-US" dirty="0"/>
           </a:p>
@@ -9504,7 +9507,7 @@
           <a:p>
             <a:fld id="{48A87A34-81AB-432B-8DAE-1953F412C126}" type="datetimeFigureOut">
               <a:rPr lang="en-US" smtClean="0"/>
-              <a:t>8/1/2025</a:t>
+              <a:t>8/12/2025</a:t>
             </a:fld>
             <a:endParaRPr lang="en-US" dirty="0"/>
           </a:p>
@@ -12582,7 +12585,7 @@
             <a:fld id="{48A87A34-81AB-432B-8DAE-1953F412C126}" type="datetimeFigureOut">
               <a:rPr lang="en-US" smtClean="0"/>
               <a:pPr/>
-              <a:t>8/1/2025</a:t>
+              <a:t>8/12/2025</a:t>
             </a:fld>
             <a:endParaRPr lang="en-US" dirty="0"/>
           </a:p>
@@ -13029,34 +13032,22 @@
             <a:pPr algn="ctr"/>
             <a:r>
               <a:rPr lang="en-US" sz="5400" b="1" dirty="0">
-                <a:solidFill>
-                  <a:schemeClr val="bg1"/>
-                </a:solidFill>
                 <a:latin typeface="Rockwell" panose="02060603020205020403" pitchFamily="18" charset="0"/>
               </a:rPr>
               <a:t>MENTAL HEALTH DETECTOR</a:t>
             </a:r>
             <a:br>
               <a:rPr lang="en-US" sz="5400" b="1" dirty="0">
-                <a:solidFill>
-                  <a:schemeClr val="bg1"/>
-                </a:solidFill>
                 <a:latin typeface="Rockwell" panose="02060603020205020403" pitchFamily="18" charset="0"/>
               </a:rPr>
             </a:br>
             <a:br>
               <a:rPr lang="en-US" sz="5400" dirty="0">
-                <a:solidFill>
-                  <a:schemeClr val="bg1"/>
-                </a:solidFill>
                 <a:latin typeface="Rockwell" panose="02060603020205020403" pitchFamily="18" charset="0"/>
               </a:rPr>
             </a:br>
             <a:r>
               <a:rPr lang="en-US" sz="2700" dirty="0">
-                <a:solidFill>
-                  <a:schemeClr val="bg1"/>
-                </a:solidFill>
                 <a:latin typeface="Rockwell" panose="02060603020205020403" pitchFamily="18" charset="0"/>
               </a:rPr>
               <a:t>AN AI-POWERED TOOL FOR DETECTION AND TREATMENT OF MENTAL HEALTH DISORDERS</a:t>
@@ -13099,7 +13090,7 @@
             <a:r>
               <a:rPr lang="en-US" sz="2400" dirty="0">
                 <a:solidFill>
-                  <a:schemeClr val="bg1"/>
+                  <a:schemeClr val="tx1"/>
                 </a:solidFill>
                 <a:latin typeface="Tahoma" panose="020B0604030504040204" pitchFamily="34" charset="0"/>
                 <a:ea typeface="Tahoma" panose="020B0604030504040204" pitchFamily="34" charset="0"/>
@@ -13132,6 +13123,221 @@
 </file>
 
 <file path=ppt/slides/slide10.xml><?xml version="1.0" encoding="utf-8"?>
+<p:sld xmlns:a="http://schemas.openxmlformats.org/drawingml/2006/main" xmlns:r="http://schemas.openxmlformats.org/officeDocument/2006/relationships" xmlns:p="http://schemas.openxmlformats.org/presentationml/2006/main">
+  <p:cSld>
+    <p:spTree>
+      <p:nvGrpSpPr>
+        <p:cNvPr id="1" name=""/>
+        <p:cNvGrpSpPr/>
+        <p:nvPr/>
+      </p:nvGrpSpPr>
+      <p:grpSpPr>
+        <a:xfrm>
+          <a:off x="0" y="0"/>
+          <a:ext cx="0" cy="0"/>
+          <a:chOff x="0" y="0"/>
+          <a:chExt cx="0" cy="0"/>
+        </a:xfrm>
+      </p:grpSpPr>
+      <p:sp>
+        <p:nvSpPr>
+          <p:cNvPr id="2" name="Title 1">
+            <a:extLst>
+              <a:ext uri="{FF2B5EF4-FFF2-40B4-BE49-F238E27FC236}">
+                <a16:creationId xmlns:a16="http://schemas.microsoft.com/office/drawing/2014/main" id="{9FC2FFC0-03FB-BF0B-9FDA-F0F111D43D3F}"/>
+              </a:ext>
+            </a:extLst>
+          </p:cNvPr>
+          <p:cNvSpPr>
+            <a:spLocks noGrp="1"/>
+          </p:cNvSpPr>
+          <p:nvPr>
+            <p:ph type="title"/>
+          </p:nvPr>
+        </p:nvSpPr>
+        <p:spPr>
+          <a:xfrm>
+            <a:off x="1141413" y="0"/>
+            <a:ext cx="9905998" cy="1066799"/>
+          </a:xfrm>
+        </p:spPr>
+        <p:txBody>
+          <a:bodyPr/>
+          <a:lstStyle/>
+          <a:p>
+            <a:r>
+              <a:rPr lang="en-US" b="1" u="sng" dirty="0"/>
+              <a:t>MODEL INTERPRETABILITY AND EVALUATION</a:t>
+            </a:r>
+          </a:p>
+        </p:txBody>
+      </p:sp>
+      <p:sp>
+        <p:nvSpPr>
+          <p:cNvPr id="3" name="Content Placeholder 2">
+            <a:extLst>
+              <a:ext uri="{FF2B5EF4-FFF2-40B4-BE49-F238E27FC236}">
+                <a16:creationId xmlns:a16="http://schemas.microsoft.com/office/drawing/2014/main" id="{917A464B-0220-F4AA-19D9-4A314A2A0154}"/>
+              </a:ext>
+            </a:extLst>
+          </p:cNvPr>
+          <p:cNvSpPr>
+            <a:spLocks noGrp="1"/>
+          </p:cNvSpPr>
+          <p:nvPr>
+            <p:ph idx="1"/>
+          </p:nvPr>
+        </p:nvSpPr>
+        <p:spPr>
+          <a:xfrm>
+            <a:off x="1141412" y="898358"/>
+            <a:ext cx="9905999" cy="5245768"/>
+          </a:xfrm>
+        </p:spPr>
+        <p:txBody>
+          <a:bodyPr>
+            <a:normAutofit fontScale="92500" lnSpcReduction="10000"/>
+          </a:bodyPr>
+          <a:lstStyle/>
+          <a:p>
+            <a:pPr marL="457200" indent="-457200">
+              <a:buFont typeface="+mj-lt"/>
+              <a:buAutoNum type="arabicPeriod"/>
+            </a:pPr>
+            <a:r>
+              <a:rPr lang="en-US" b="1" dirty="0"/>
+              <a:t>Text-based model </a:t>
+            </a:r>
+            <a:r>
+              <a:rPr lang="en-US" dirty="0"/>
+              <a:t>(sentenceBERT + multi-label classifier)</a:t>
+            </a:r>
+          </a:p>
+          <a:p>
+            <a:pPr lvl="1"/>
+            <a:r>
+              <a:rPr lang="en-US" b="1" dirty="0"/>
+              <a:t>Goal</a:t>
+            </a:r>
+            <a:r>
+              <a:rPr lang="en-US" dirty="0"/>
+              <a:t>: Detect mental health conditions (e.g., anxiety, depression, burnout) from symptom descriptions</a:t>
+            </a:r>
+          </a:p>
+          <a:p>
+            <a:pPr lvl="1"/>
+            <a:r>
+              <a:rPr lang="en-US" b="1" dirty="0"/>
+              <a:t>Evaluation Metrics</a:t>
+            </a:r>
+            <a:r>
+              <a:rPr lang="en-US" dirty="0"/>
+              <a:t>:</a:t>
+            </a:r>
+          </a:p>
+          <a:p>
+            <a:pPr lvl="3"/>
+            <a:r>
+              <a:rPr lang="en-US" b="1" dirty="0"/>
+              <a:t>Hamming Loss:</a:t>
+            </a:r>
+          </a:p>
+          <a:p>
+            <a:pPr lvl="3"/>
+            <a:r>
+              <a:rPr lang="en-US" b="1" dirty="0"/>
+              <a:t>Subset Accuracy: 81%</a:t>
+            </a:r>
+            <a:endParaRPr lang="en-US" dirty="0"/>
+          </a:p>
+          <a:p>
+            <a:pPr lvl="3"/>
+            <a:r>
+              <a:rPr lang="en-US" b="1" dirty="0"/>
+              <a:t>Macro F1-score.</a:t>
+            </a:r>
+            <a:endParaRPr lang="en-US" dirty="0"/>
+          </a:p>
+          <a:p>
+            <a:pPr marL="457200" indent="-457200">
+              <a:buFont typeface="+mj-lt"/>
+              <a:buAutoNum type="arabicPeriod"/>
+            </a:pPr>
+            <a:r>
+              <a:rPr lang="en-US" b="1" dirty="0"/>
+              <a:t>Structured data model </a:t>
+            </a:r>
+            <a:r>
+              <a:rPr lang="en-US" dirty="0"/>
+              <a:t>(CatBoostClassifier)</a:t>
+            </a:r>
+          </a:p>
+          <a:p>
+            <a:pPr lvl="1"/>
+            <a:r>
+              <a:rPr lang="en-US" b="1" dirty="0"/>
+              <a:t>Models: </a:t>
+            </a:r>
+            <a:r>
+              <a:rPr lang="en-US" dirty="0"/>
+              <a:t>We used a stacked model of catboost and lightgbm</a:t>
+            </a:r>
+          </a:p>
+          <a:p>
+            <a:pPr lvl="1"/>
+            <a:r>
+              <a:rPr lang="en-US" b="1" dirty="0"/>
+              <a:t>Goal</a:t>
+            </a:r>
+            <a:r>
+              <a:rPr lang="en-US" dirty="0"/>
+              <a:t>: Predict mental health conditions &amp; severity from lifestyle features</a:t>
+            </a:r>
+          </a:p>
+          <a:p>
+            <a:pPr lvl="1"/>
+            <a:r>
+              <a:rPr lang="en-US" dirty="0"/>
+              <a:t>Evaluation metrics:</a:t>
+            </a:r>
+          </a:p>
+          <a:p>
+            <a:pPr lvl="2"/>
+            <a:r>
+              <a:rPr lang="en-US" dirty="0"/>
+              <a:t>Accuracy: 83%</a:t>
+            </a:r>
+          </a:p>
+          <a:p>
+            <a:pPr lvl="2"/>
+            <a:r>
+              <a:rPr lang="en-US" dirty="0"/>
+              <a:t>Marco F1-score.</a:t>
+            </a:r>
+          </a:p>
+          <a:p>
+            <a:pPr lvl="2"/>
+            <a:r>
+              <a:rPr lang="en-US" dirty="0"/>
+              <a:t>Weighted f1-score.</a:t>
+            </a:r>
+          </a:p>
+        </p:txBody>
+      </p:sp>
+    </p:spTree>
+    <p:extLst>
+      <p:ext uri="{BB962C8B-B14F-4D97-AF65-F5344CB8AC3E}">
+        <p14:creationId xmlns:p14="http://schemas.microsoft.com/office/powerpoint/2010/main" val="4238847071"/>
+      </p:ext>
+    </p:extLst>
+  </p:cSld>
+  <p:clrMapOvr>
+    <a:masterClrMapping/>
+  </p:clrMapOvr>
+</p:sld>
+</file>
+
+<file path=ppt/slides/slide11.xml><?xml version="1.0" encoding="utf-8"?>
 <p:sld xmlns:a="http://schemas.openxmlformats.org/drawingml/2006/main" xmlns:r="http://schemas.openxmlformats.org/officeDocument/2006/relationships" xmlns:p="http://schemas.openxmlformats.org/presentationml/2006/main">
   <p:cSld>
     <p:spTree>
@@ -13176,7 +13382,7 @@
           <a:p>
             <a:r>
               <a:rPr lang="en-US" b="1" u="sng" dirty="0"/>
-              <a:t>SYSTEM DESIGN</a:t>
+              <a:t>DEPLOYMENT</a:t>
             </a:r>
           </a:p>
         </p:txBody>
@@ -13205,7 +13411,7 @@
         </p:spPr>
         <p:txBody>
           <a:bodyPr>
-            <a:normAutofit lnSpcReduction="10000"/>
+            <a:normAutofit fontScale="85000" lnSpcReduction="20000"/>
           </a:bodyPr>
           <a:lstStyle/>
           <a:p>
@@ -13215,7 +13421,82 @@
             </a:r>
             <a:r>
               <a:rPr lang="en-US" dirty="0"/>
-              <a:t>: Streamlit web app</a:t>
+              <a:t>: </a:t>
+            </a:r>
+          </a:p>
+          <a:p>
+            <a:pPr marL="457200" lvl="1" indent="0">
+              <a:buNone/>
+            </a:pPr>
+            <a:r>
+              <a:rPr lang="en-US" dirty="0"/>
+              <a:t>1. </a:t>
+            </a:r>
+            <a:r>
+              <a:rPr lang="en-US" dirty="0" err="1"/>
+              <a:t>Streamlit</a:t>
+            </a:r>
+            <a:r>
+              <a:rPr lang="en-US" dirty="0"/>
+              <a:t> - </a:t>
+            </a:r>
+            <a:r>
+              <a:rPr lang="en-US" dirty="0" err="1"/>
+              <a:t>Streamlit</a:t>
+            </a:r>
+            <a:r>
+              <a:rPr lang="en-US" dirty="0"/>
+              <a:t> let us run the </a:t>
+            </a:r>
+            <a:r>
+              <a:rPr lang="en-US" dirty="0" err="1"/>
+              <a:t>api</a:t>
+            </a:r>
+            <a:r>
+              <a:rPr lang="en-US" dirty="0"/>
+              <a:t> locally.</a:t>
+            </a:r>
+          </a:p>
+          <a:p>
+            <a:pPr marL="457200" lvl="1" indent="0">
+              <a:buNone/>
+            </a:pPr>
+            <a:r>
+              <a:rPr lang="en-US" dirty="0"/>
+              <a:t>2. API - We built a </a:t>
+            </a:r>
+            <a:r>
+              <a:rPr lang="en-US" dirty="0" err="1"/>
+              <a:t>FastAPI</a:t>
+            </a:r>
+            <a:r>
+              <a:rPr lang="en-US" dirty="0"/>
+              <a:t> backend for scalable inference.</a:t>
+            </a:r>
+          </a:p>
+          <a:p>
+            <a:pPr marL="457200" lvl="1" indent="0">
+              <a:buNone/>
+            </a:pPr>
+            <a:r>
+              <a:rPr lang="en-US" dirty="0"/>
+              <a:t>3. </a:t>
+            </a:r>
+            <a:r>
+              <a:rPr lang="en-US" dirty="0" err="1"/>
+              <a:t>Ngrok</a:t>
+            </a:r>
+            <a:r>
+              <a:rPr lang="en-US" dirty="0"/>
+              <a:t> - </a:t>
+            </a:r>
+            <a:r>
+              <a:rPr lang="en-US" dirty="0" err="1"/>
+              <a:t>ngrok</a:t>
+            </a:r>
+            <a:r>
+              <a:rPr lang="en-US" dirty="0"/>
+              <a:t> will let us deploy to the internet for testing.</a:t>
             </a:r>
           </a:p>
           <a:p>
@@ -13259,7 +13540,7 @@
             </a:pPr>
             <a:r>
               <a:rPr lang="en-US" dirty="0" err="1"/>
-              <a:t>model_nlp.pkl</a:t>
+              <a:t>Model_nlp.pkl</a:t>
             </a:r>
             <a:r>
               <a:rPr lang="en-US" dirty="0"/>
@@ -13317,6 +13598,280 @@
               <a:rPr lang="en-US" dirty="0"/>
               <a:t>Label encoders for categorical inputs</a:t>
             </a:r>
+          </a:p>
+        </p:txBody>
+      </p:sp>
+      <p:sp>
+        <p:nvSpPr>
+          <p:cNvPr id="4" name="Rectangle 1">
+            <a:extLst>
+              <a:ext uri="{FF2B5EF4-FFF2-40B4-BE49-F238E27FC236}">
+                <a16:creationId xmlns:a16="http://schemas.microsoft.com/office/drawing/2014/main" id="{6D4BA857-32DC-2366-CBD6-F890F6BEE123}"/>
+              </a:ext>
+            </a:extLst>
+          </p:cNvPr>
+          <p:cNvSpPr>
+            <a:spLocks noChangeArrowheads="1"/>
+          </p:cNvSpPr>
+          <p:nvPr/>
+        </p:nvSpPr>
+        <p:spPr bwMode="auto">
+          <a:xfrm>
+            <a:off x="0" y="0"/>
+            <a:ext cx="12192000" cy="0"/>
+          </a:xfrm>
+          <a:prstGeom prst="rect">
+            <a:avLst/>
+          </a:prstGeom>
+          <a:noFill/>
+          <a:ln>
+            <a:noFill/>
+          </a:ln>
+          <a:effectLst/>
+          <a:extLst>
+            <a:ext uri="{909E8E84-426E-40DD-AFC4-6F175D3DCCD1}">
+              <a14:hiddenFill xmlns:a14="http://schemas.microsoft.com/office/drawing/2010/main">
+                <a:solidFill>
+                  <a:schemeClr val="accent1"/>
+                </a:solidFill>
+              </a14:hiddenFill>
+            </a:ext>
+            <a:ext uri="{91240B29-F687-4F45-9708-019B960494DF}">
+              <a14:hiddenLine xmlns:a14="http://schemas.microsoft.com/office/drawing/2010/main" w="9525">
+                <a:solidFill>
+                  <a:schemeClr val="tx1"/>
+                </a:solidFill>
+                <a:miter lim="800000"/>
+                <a:headEnd/>
+                <a:tailEnd/>
+              </a14:hiddenLine>
+            </a:ext>
+            <a:ext uri="{AF507438-7753-43E0-B8FC-AC1667EBCBE1}">
+              <a14:hiddenEffects xmlns:a14="http://schemas.microsoft.com/office/drawing/2010/main">
+                <a:effectLst>
+                  <a:outerShdw dist="35921" dir="2700000" algn="ctr" rotWithShape="0">
+                    <a:schemeClr val="bg2"/>
+                  </a:outerShdw>
+                </a:effectLst>
+              </a14:hiddenEffects>
+            </a:ext>
+          </a:extLst>
+        </p:spPr>
+        <p:txBody>
+          <a:bodyPr vert="horz" wrap="none" lIns="91440" tIns="45720" rIns="91440" bIns="45720" numCol="1" anchor="ctr" anchorCtr="0" compatLnSpc="1">
+            <a:prstTxWarp prst="textNoShape">
+              <a:avLst/>
+            </a:prstTxWarp>
+            <a:spAutoFit/>
+          </a:bodyPr>
+          <a:lstStyle>
+            <a:lvl1pPr eaLnBrk="0" fontAlgn="base" hangingPunct="0">
+              <a:spcBef>
+                <a:spcPct val="0"/>
+              </a:spcBef>
+              <a:spcAft>
+                <a:spcPct val="0"/>
+              </a:spcAft>
+              <a:defRPr>
+                <a:solidFill>
+                  <a:schemeClr val="tx1"/>
+                </a:solidFill>
+                <a:latin typeface="Arial" panose="020B0604020202020204" pitchFamily="34" charset="0"/>
+              </a:defRPr>
+            </a:lvl1pPr>
+            <a:lvl2pPr eaLnBrk="0" fontAlgn="base" hangingPunct="0">
+              <a:spcBef>
+                <a:spcPct val="0"/>
+              </a:spcBef>
+              <a:spcAft>
+                <a:spcPct val="0"/>
+              </a:spcAft>
+              <a:defRPr>
+                <a:solidFill>
+                  <a:schemeClr val="tx1"/>
+                </a:solidFill>
+                <a:latin typeface="Arial" panose="020B0604020202020204" pitchFamily="34" charset="0"/>
+              </a:defRPr>
+            </a:lvl2pPr>
+            <a:lvl3pPr eaLnBrk="0" fontAlgn="base" hangingPunct="0">
+              <a:spcBef>
+                <a:spcPct val="0"/>
+              </a:spcBef>
+              <a:spcAft>
+                <a:spcPct val="0"/>
+              </a:spcAft>
+              <a:defRPr>
+                <a:solidFill>
+                  <a:schemeClr val="tx1"/>
+                </a:solidFill>
+                <a:latin typeface="Arial" panose="020B0604020202020204" pitchFamily="34" charset="0"/>
+              </a:defRPr>
+            </a:lvl3pPr>
+            <a:lvl4pPr eaLnBrk="0" fontAlgn="base" hangingPunct="0">
+              <a:spcBef>
+                <a:spcPct val="0"/>
+              </a:spcBef>
+              <a:spcAft>
+                <a:spcPct val="0"/>
+              </a:spcAft>
+              <a:defRPr>
+                <a:solidFill>
+                  <a:schemeClr val="tx1"/>
+                </a:solidFill>
+                <a:latin typeface="Arial" panose="020B0604020202020204" pitchFamily="34" charset="0"/>
+              </a:defRPr>
+            </a:lvl4pPr>
+            <a:lvl5pPr eaLnBrk="0" fontAlgn="base" hangingPunct="0">
+              <a:spcBef>
+                <a:spcPct val="0"/>
+              </a:spcBef>
+              <a:spcAft>
+                <a:spcPct val="0"/>
+              </a:spcAft>
+              <a:defRPr>
+                <a:solidFill>
+                  <a:schemeClr val="tx1"/>
+                </a:solidFill>
+                <a:latin typeface="Arial" panose="020B0604020202020204" pitchFamily="34" charset="0"/>
+              </a:defRPr>
+            </a:lvl5pPr>
+            <a:lvl6pPr eaLnBrk="0" fontAlgn="base" hangingPunct="0">
+              <a:spcBef>
+                <a:spcPct val="0"/>
+              </a:spcBef>
+              <a:spcAft>
+                <a:spcPct val="0"/>
+              </a:spcAft>
+              <a:defRPr>
+                <a:solidFill>
+                  <a:schemeClr val="tx1"/>
+                </a:solidFill>
+                <a:latin typeface="Arial" panose="020B0604020202020204" pitchFamily="34" charset="0"/>
+              </a:defRPr>
+            </a:lvl6pPr>
+            <a:lvl7pPr eaLnBrk="0" fontAlgn="base" hangingPunct="0">
+              <a:spcBef>
+                <a:spcPct val="0"/>
+              </a:spcBef>
+              <a:spcAft>
+                <a:spcPct val="0"/>
+              </a:spcAft>
+              <a:defRPr>
+                <a:solidFill>
+                  <a:schemeClr val="tx1"/>
+                </a:solidFill>
+                <a:latin typeface="Arial" panose="020B0604020202020204" pitchFamily="34" charset="0"/>
+              </a:defRPr>
+            </a:lvl7pPr>
+            <a:lvl8pPr eaLnBrk="0" fontAlgn="base" hangingPunct="0">
+              <a:spcBef>
+                <a:spcPct val="0"/>
+              </a:spcBef>
+              <a:spcAft>
+                <a:spcPct val="0"/>
+              </a:spcAft>
+              <a:defRPr>
+                <a:solidFill>
+                  <a:schemeClr val="tx1"/>
+                </a:solidFill>
+                <a:latin typeface="Arial" panose="020B0604020202020204" pitchFamily="34" charset="0"/>
+              </a:defRPr>
+            </a:lvl8pPr>
+            <a:lvl9pPr eaLnBrk="0" fontAlgn="base" hangingPunct="0">
+              <a:spcBef>
+                <a:spcPct val="0"/>
+              </a:spcBef>
+              <a:spcAft>
+                <a:spcPct val="0"/>
+              </a:spcAft>
+              <a:defRPr>
+                <a:solidFill>
+                  <a:schemeClr val="tx1"/>
+                </a:solidFill>
+                <a:latin typeface="Arial" panose="020B0604020202020204" pitchFamily="34" charset="0"/>
+              </a:defRPr>
+            </a:lvl9pPr>
+          </a:lstStyle>
+          <a:p>
+            <a:pPr marL="0" marR="0" lvl="0" indent="0" algn="ctr" defTabSz="914400" rtl="0" eaLnBrk="0" fontAlgn="base" latinLnBrk="0" hangingPunct="0">
+              <a:lnSpc>
+                <a:spcPct val="100000"/>
+              </a:lnSpc>
+              <a:spcBef>
+                <a:spcPct val="0"/>
+              </a:spcBef>
+              <a:spcAft>
+                <a:spcPct val="0"/>
+              </a:spcAft>
+              <a:buClrTx/>
+              <a:buSzTx/>
+              <a:buFontTx/>
+              <a:buNone/>
+              <a:tabLst/>
+            </a:pPr>
+            <a:r>
+              <a:rPr kumimoji="0" lang="en-US" altLang="en-US" sz="1800" b="0" i="0" u="none" strike="noStrike" cap="none" normalizeH="0" baseline="0">
+                <a:ln>
+                  <a:noFill/>
+                </a:ln>
+                <a:solidFill>
+                  <a:srgbClr val="1F1F1F"/>
+                </a:solidFill>
+                <a:effectLst/>
+                <a:latin typeface="Google Sans"/>
+              </a:rPr>
+              <a:t>Streamlit let us run the api locally.</a:t>
+            </a:r>
+            <a:endParaRPr kumimoji="0" lang="en-US" altLang="en-US" sz="1800" b="0" i="0" u="none" strike="noStrike" cap="none" normalizeH="0" baseline="0">
+              <a:ln>
+                <a:noFill/>
+              </a:ln>
+              <a:solidFill>
+                <a:schemeClr val="tx1"/>
+              </a:solidFill>
+              <a:effectLst/>
+              <a:latin typeface="Google Sans"/>
+            </a:endParaRPr>
+          </a:p>
+          <a:p>
+            <a:pPr marL="0" marR="0" lvl="0" indent="0" algn="ctr" defTabSz="914400" rtl="0" eaLnBrk="0" fontAlgn="base" latinLnBrk="0" hangingPunct="0">
+              <a:lnSpc>
+                <a:spcPct val="100000"/>
+              </a:lnSpc>
+              <a:spcBef>
+                <a:spcPct val="0"/>
+              </a:spcBef>
+              <a:spcAft>
+                <a:spcPct val="0"/>
+              </a:spcAft>
+              <a:buClrTx/>
+              <a:buSzTx/>
+              <a:buFontTx/>
+              <a:buNone/>
+              <a:tabLst/>
+            </a:pPr>
+            <a:br>
+              <a:rPr kumimoji="0" lang="en-US" altLang="en-US" sz="900" b="0" i="0" u="none" strike="noStrike" cap="none" normalizeH="0" baseline="0">
+                <a:ln>
+                  <a:noFill/>
+                </a:ln>
+                <a:solidFill>
+                  <a:srgbClr val="FFFFFF"/>
+                </a:solidFill>
+                <a:effectLst/>
+                <a:latin typeface="Roboto" panose="02000000000000000000" pitchFamily="2" charset="0"/>
+              </a:rPr>
+            </a:br>
+            <a:endParaRPr kumimoji="0" lang="en-US" altLang="en-US" sz="1800" b="0" i="0" u="none" strike="noStrike" cap="none" normalizeH="0" baseline="0">
+              <a:ln>
+                <a:noFill/>
+              </a:ln>
+              <a:solidFill>
+                <a:schemeClr val="tx1"/>
+              </a:solidFill>
+              <a:effectLst/>
+              <a:latin typeface="Arial" panose="020B0604020202020204" pitchFamily="34" charset="0"/>
+            </a:endParaRPr>
           </a:p>
         </p:txBody>
       </p:sp>
@@ -13333,7 +13888,7 @@
 </p:sld>
 </file>
 
-<file path=ppt/slides/slide11.xml><?xml version="1.0" encoding="utf-8"?>
+<file path=ppt/slides/slide12.xml><?xml version="1.0" encoding="utf-8"?>
 <p:sld xmlns:a="http://schemas.openxmlformats.org/drawingml/2006/main" xmlns:r="http://schemas.openxmlformats.org/officeDocument/2006/relationships" xmlns:p="http://schemas.openxmlformats.org/presentationml/2006/main">
   <p:cSld>
     <p:spTree>
@@ -13406,11 +13961,16 @@
           </a:xfrm>
         </p:spPr>
         <p:txBody>
-          <a:bodyPr/>
+          <a:bodyPr>
+            <a:normAutofit fontScale="92500" lnSpcReduction="10000"/>
+          </a:bodyPr>
           <a:lstStyle/>
           <a:p>
-            <a:r>
-              <a:rPr lang="en-US" dirty="0"/>
+            <a:pPr marL="0" indent="0">
+              <a:buNone/>
+            </a:pPr>
+            <a:r>
+              <a:rPr lang="en-US" b="1" dirty="0"/>
               <a:t>Prediction flow</a:t>
             </a:r>
           </a:p>
@@ -13449,14 +14009,14 @@
             <a:pPr lvl="2"/>
             <a:r>
               <a:rPr lang="en-US" dirty="0"/>
-              <a:t>Top 3 disorders shown, with one identified as top concern</a:t>
+              <a:t>Top 3 disorders shown, with one identified as the top concern</a:t>
             </a:r>
           </a:p>
           <a:p>
             <a:pPr lvl="2"/>
             <a:r>
               <a:rPr lang="en-US" dirty="0"/>
-              <a:t>Recommendations retrieved from data base based on predicted disorder</a:t>
+              <a:t>Recommendations retrieved from the base based on predicted disorder</a:t>
             </a:r>
           </a:p>
           <a:p>
@@ -13531,6 +14091,20 @@
             <a:r>
               <a:rPr lang="en-US" dirty="0"/>
               <a:t>)</a:t>
+            </a:r>
+          </a:p>
+          <a:p>
+            <a:pPr lvl="2"/>
+            <a:r>
+              <a:rPr lang="en-US" dirty="0"/>
+              <a:t>Then adds recommendations and tips for the disorder</a:t>
+            </a:r>
+          </a:p>
+          <a:p>
+            <a:pPr lvl="2"/>
+            <a:r>
+              <a:rPr lang="en-US" dirty="0"/>
+              <a:t>Also has an option to download csv</a:t>
             </a:r>
           </a:p>
         </p:txBody>
@@ -13548,7 +14122,7 @@
 </p:sld>
 </file>
 
-<file path=ppt/slides/slide12.xml><?xml version="1.0" encoding="utf-8"?>
+<file path=ppt/slides/slide13.xml><?xml version="1.0" encoding="utf-8"?>
 <p:sld xmlns:a="http://schemas.openxmlformats.org/drawingml/2006/main" xmlns:r="http://schemas.openxmlformats.org/officeDocument/2006/relationships" xmlns:p="http://schemas.openxmlformats.org/presentationml/2006/main">
   <p:cSld>
     <p:spTree>
@@ -13662,7 +14236,316 @@
 </p:sld>
 </file>
 
-<file path=ppt/slides/slide13.xml><?xml version="1.0" encoding="utf-8"?>
+<file path=ppt/slides/slide14.xml><?xml version="1.0" encoding="utf-8"?>
+<p:sld xmlns:a="http://schemas.openxmlformats.org/drawingml/2006/main" xmlns:r="http://schemas.openxmlformats.org/officeDocument/2006/relationships" xmlns:p="http://schemas.openxmlformats.org/presentationml/2006/main">
+  <p:cSld>
+    <p:spTree>
+      <p:nvGrpSpPr>
+        <p:cNvPr id="1" name=""/>
+        <p:cNvGrpSpPr/>
+        <p:nvPr/>
+      </p:nvGrpSpPr>
+      <p:grpSpPr>
+        <a:xfrm>
+          <a:off x="0" y="0"/>
+          <a:ext cx="0" cy="0"/>
+          <a:chOff x="0" y="0"/>
+          <a:chExt cx="0" cy="0"/>
+        </a:xfrm>
+      </p:grpSpPr>
+      <p:sp>
+        <p:nvSpPr>
+          <p:cNvPr id="2" name="Title 1">
+            <a:extLst>
+              <a:ext uri="{FF2B5EF4-FFF2-40B4-BE49-F238E27FC236}">
+                <a16:creationId xmlns:a16="http://schemas.microsoft.com/office/drawing/2014/main" id="{EB0450BF-0AA7-93A8-61BE-456C1284E992}"/>
+              </a:ext>
+            </a:extLst>
+          </p:cNvPr>
+          <p:cNvSpPr>
+            <a:spLocks noGrp="1"/>
+          </p:cNvSpPr>
+          <p:nvPr>
+            <p:ph type="title"/>
+          </p:nvPr>
+        </p:nvSpPr>
+        <p:spPr>
+          <a:xfrm>
+            <a:off x="1141413" y="0"/>
+            <a:ext cx="9905998" cy="1066799"/>
+          </a:xfrm>
+        </p:spPr>
+        <p:txBody>
+          <a:bodyPr/>
+          <a:lstStyle/>
+          <a:p>
+            <a:r>
+              <a:rPr lang="en-US" b="1" u="sng" dirty="0"/>
+              <a:t>RECOMENDATIONS</a:t>
+            </a:r>
+          </a:p>
+        </p:txBody>
+      </p:sp>
+      <p:sp>
+        <p:nvSpPr>
+          <p:cNvPr id="3" name="Content Placeholder 2">
+            <a:extLst>
+              <a:ext uri="{FF2B5EF4-FFF2-40B4-BE49-F238E27FC236}">
+                <a16:creationId xmlns:a16="http://schemas.microsoft.com/office/drawing/2014/main" id="{9E898138-2463-3D57-C558-A1DE2E33C431}"/>
+              </a:ext>
+            </a:extLst>
+          </p:cNvPr>
+          <p:cNvSpPr>
+            <a:spLocks noGrp="1"/>
+          </p:cNvSpPr>
+          <p:nvPr>
+            <p:ph idx="1"/>
+          </p:nvPr>
+        </p:nvSpPr>
+        <p:spPr>
+          <a:xfrm>
+            <a:off x="1141412" y="1066799"/>
+            <a:ext cx="9905999" cy="4724402"/>
+          </a:xfrm>
+        </p:spPr>
+        <p:txBody>
+          <a:bodyPr>
+            <a:normAutofit lnSpcReduction="10000"/>
+          </a:bodyPr>
+          <a:lstStyle/>
+          <a:p>
+            <a:pPr marL="457200" indent="-457200">
+              <a:buFont typeface="+mj-lt"/>
+              <a:buAutoNum type="arabicPeriod"/>
+            </a:pPr>
+            <a:r>
+              <a:rPr lang="en-US" dirty="0"/>
+              <a:t> </a:t>
+            </a:r>
+            <a:r>
+              <a:rPr lang="en-US" b="1" dirty="0"/>
+              <a:t>Model Performance Improvement </a:t>
+            </a:r>
+            <a:r>
+              <a:rPr lang="en-US" dirty="0"/>
+              <a:t>- Enhance the classifier’s accuracy by experimenting with more advanced NLP embeddings (e.g., OpenAI embeddings, </a:t>
+            </a:r>
+            <a:r>
+              <a:rPr lang="en-US" dirty="0" err="1"/>
+              <a:t>ClinicalBERT</a:t>
+            </a:r>
+            <a:r>
+              <a:rPr lang="en-US" dirty="0"/>
+              <a:t>, or </a:t>
+            </a:r>
+            <a:r>
+              <a:rPr lang="en-US" dirty="0" err="1"/>
+              <a:t>BioBERT</a:t>
+            </a:r>
+            <a:r>
+              <a:rPr lang="en-US" dirty="0"/>
+              <a:t>) for the signs-based model.</a:t>
+            </a:r>
+          </a:p>
+          <a:p>
+            <a:pPr marL="457200" indent="-457200">
+              <a:buFont typeface="+mj-lt"/>
+              <a:buAutoNum type="arabicPeriod"/>
+            </a:pPr>
+            <a:r>
+              <a:rPr lang="en-US" b="1" dirty="0"/>
+              <a:t>User-Centric Refinement </a:t>
+            </a:r>
+            <a:r>
+              <a:rPr lang="en-US" dirty="0"/>
+              <a:t>- Integrate user feedback within the UI to refine predictions and recommendations dynamically over time.</a:t>
+            </a:r>
+          </a:p>
+          <a:p>
+            <a:pPr marL="457200" indent="-457200">
+              <a:buFont typeface="+mj-lt"/>
+              <a:buAutoNum type="arabicPeriod"/>
+            </a:pPr>
+            <a:r>
+              <a:rPr lang="en-US" b="1" dirty="0"/>
+              <a:t>Integration of Multi-Source Data </a:t>
+            </a:r>
+            <a:r>
+              <a:rPr lang="en-US" dirty="0"/>
+              <a:t>- Combine self-reported lifestyle features with wearable health tracker data (sleep quality, heart rate, activity logs) to improve prediction reliability.</a:t>
+            </a:r>
+          </a:p>
+          <a:p>
+            <a:pPr marL="457200" indent="-457200">
+              <a:buFont typeface="+mj-lt"/>
+              <a:buAutoNum type="arabicPeriod"/>
+            </a:pPr>
+            <a:r>
+              <a:rPr lang="en-US" b="1" dirty="0"/>
+              <a:t>Privacy and Ethics </a:t>
+            </a:r>
+            <a:r>
+              <a:rPr lang="en-US" dirty="0"/>
+              <a:t>- Implement robust data encryption and anonymization for all stored or transmitted user inputs.</a:t>
+            </a:r>
+          </a:p>
+          <a:p>
+            <a:pPr marL="0" indent="0">
+              <a:buNone/>
+            </a:pPr>
+            <a:endParaRPr lang="en-US" dirty="0"/>
+          </a:p>
+        </p:txBody>
+      </p:sp>
+    </p:spTree>
+    <p:extLst>
+      <p:ext uri="{BB962C8B-B14F-4D97-AF65-F5344CB8AC3E}">
+        <p14:creationId xmlns:p14="http://schemas.microsoft.com/office/powerpoint/2010/main" val="3641268037"/>
+      </p:ext>
+    </p:extLst>
+  </p:cSld>
+  <p:clrMapOvr>
+    <a:masterClrMapping/>
+  </p:clrMapOvr>
+</p:sld>
+</file>
+
+<file path=ppt/slides/slide15.xml><?xml version="1.0" encoding="utf-8"?>
+<p:sld xmlns:a="http://schemas.openxmlformats.org/drawingml/2006/main" xmlns:r="http://schemas.openxmlformats.org/officeDocument/2006/relationships" xmlns:p="http://schemas.openxmlformats.org/presentationml/2006/main">
+  <p:cSld>
+    <p:spTree>
+      <p:nvGrpSpPr>
+        <p:cNvPr id="1" name=""/>
+        <p:cNvGrpSpPr/>
+        <p:nvPr/>
+      </p:nvGrpSpPr>
+      <p:grpSpPr>
+        <a:xfrm>
+          <a:off x="0" y="0"/>
+          <a:ext cx="0" cy="0"/>
+          <a:chOff x="0" y="0"/>
+          <a:chExt cx="0" cy="0"/>
+        </a:xfrm>
+      </p:grpSpPr>
+      <p:sp>
+        <p:nvSpPr>
+          <p:cNvPr id="2" name="Title 1">
+            <a:extLst>
+              <a:ext uri="{FF2B5EF4-FFF2-40B4-BE49-F238E27FC236}">
+                <a16:creationId xmlns:a16="http://schemas.microsoft.com/office/drawing/2014/main" id="{58C855B0-22E7-F60E-03F5-5C965E659F40}"/>
+              </a:ext>
+            </a:extLst>
+          </p:cNvPr>
+          <p:cNvSpPr>
+            <a:spLocks noGrp="1"/>
+          </p:cNvSpPr>
+          <p:nvPr>
+            <p:ph type="title"/>
+          </p:nvPr>
+        </p:nvSpPr>
+        <p:spPr>
+          <a:xfrm>
+            <a:off x="1141413" y="0"/>
+            <a:ext cx="9905998" cy="802105"/>
+          </a:xfrm>
+        </p:spPr>
+        <p:txBody>
+          <a:bodyPr/>
+          <a:lstStyle/>
+          <a:p>
+            <a:r>
+              <a:rPr lang="en-US" b="1" u="sng" dirty="0"/>
+              <a:t>NEXT STEPS</a:t>
+            </a:r>
+          </a:p>
+        </p:txBody>
+      </p:sp>
+      <p:sp>
+        <p:nvSpPr>
+          <p:cNvPr id="3" name="Content Placeholder 2">
+            <a:extLst>
+              <a:ext uri="{FF2B5EF4-FFF2-40B4-BE49-F238E27FC236}">
+                <a16:creationId xmlns:a16="http://schemas.microsoft.com/office/drawing/2014/main" id="{90093229-3B70-13FE-0FD2-3E1831CE025F}"/>
+              </a:ext>
+            </a:extLst>
+          </p:cNvPr>
+          <p:cNvSpPr>
+            <a:spLocks noGrp="1"/>
+          </p:cNvSpPr>
+          <p:nvPr>
+            <p:ph idx="1"/>
+          </p:nvPr>
+        </p:nvSpPr>
+        <p:spPr>
+          <a:xfrm>
+            <a:off x="1141412" y="802105"/>
+            <a:ext cx="9905999" cy="5438274"/>
+          </a:xfrm>
+        </p:spPr>
+        <p:txBody>
+          <a:bodyPr>
+            <a:normAutofit/>
+          </a:bodyPr>
+          <a:lstStyle/>
+          <a:p>
+            <a:r>
+              <a:rPr lang="en-US" b="1" dirty="0"/>
+              <a:t>Continuous Learning System </a:t>
+            </a:r>
+            <a:r>
+              <a:rPr lang="en-US" dirty="0"/>
+              <a:t>- Build a feedback loop where user-confirmed diagnoses and lifestyle updates are fed back into the system for continuous model retraining. </a:t>
+            </a:r>
+          </a:p>
+          <a:p>
+            <a:r>
+              <a:rPr lang="en-US" b="1" dirty="0"/>
+              <a:t>Multilingual Support </a:t>
+            </a:r>
+            <a:r>
+              <a:rPr lang="en-US" dirty="0"/>
+              <a:t>- Expand the system to handle multiple languages to serve a wider audience.</a:t>
+            </a:r>
+          </a:p>
+          <a:p>
+            <a:r>
+              <a:rPr lang="en-US" b="1" dirty="0"/>
+              <a:t>Longitudinal Tracking </a:t>
+            </a:r>
+            <a:r>
+              <a:rPr lang="en-US" dirty="0"/>
+              <a:t>- Allow users to track changes in their mental health risk scores over time and correlate them with lifestyle adjustments or symptom progression. </a:t>
+            </a:r>
+          </a:p>
+          <a:p>
+            <a:r>
+              <a:rPr lang="en-US" b="1" dirty="0"/>
+              <a:t>Regulatory Compliance </a:t>
+            </a:r>
+            <a:r>
+              <a:rPr lang="en-US" dirty="0"/>
+              <a:t>- Adapt the platform to comply with HIPAA, GDPR, and other health data regulations depending on target regions for deployment.</a:t>
+            </a:r>
+          </a:p>
+          <a:p>
+            <a:endParaRPr lang="en-US" dirty="0"/>
+          </a:p>
+        </p:txBody>
+      </p:sp>
+    </p:spTree>
+    <p:extLst>
+      <p:ext uri="{BB962C8B-B14F-4D97-AF65-F5344CB8AC3E}">
+        <p14:creationId xmlns:p14="http://schemas.microsoft.com/office/powerpoint/2010/main" val="3923541076"/>
+      </p:ext>
+    </p:extLst>
+  </p:cSld>
+  <p:clrMapOvr>
+    <a:masterClrMapping/>
+  </p:clrMapOvr>
+</p:sld>
+</file>
+
+<file path=ppt/slides/slide16.xml><?xml version="1.0" encoding="utf-8"?>
 <p:sld xmlns:a="http://schemas.openxmlformats.org/drawingml/2006/main" xmlns:r="http://schemas.openxmlformats.org/officeDocument/2006/relationships" xmlns:p="http://schemas.openxmlformats.org/presentationml/2006/main">
   <p:cSld>
     <p:spTree>
@@ -13762,7 +14645,7 @@
           <p:cNvPr id="2" name="Title 1">
             <a:extLst>
               <a:ext uri="{FF2B5EF4-FFF2-40B4-BE49-F238E27FC236}">
-                <a16:creationId xmlns:a16="http://schemas.microsoft.com/office/drawing/2014/main" id="{34DB6CE4-2B13-4715-B5B2-615A55922CA1}"/>
+                <a16:creationId xmlns:a16="http://schemas.microsoft.com/office/drawing/2014/main" id="{96678FD3-A014-6906-8943-B3A2C748C755}"/>
               </a:ext>
             </a:extLst>
           </p:cNvPr>
@@ -13776,20 +14659,16 @@
         <p:spPr>
           <a:xfrm>
             <a:off x="1141413" y="0"/>
-            <a:ext cx="9905998" cy="1201271"/>
+            <a:ext cx="9905998" cy="1066799"/>
           </a:xfrm>
         </p:spPr>
         <p:txBody>
-          <a:bodyPr>
-            <a:normAutofit/>
-          </a:bodyPr>
+          <a:bodyPr/>
           <a:lstStyle/>
           <a:p>
             <a:r>
-              <a:rPr lang="en-US" sz="2800" b="1" u="sng" dirty="0">
-                <a:latin typeface="Rockwell" panose="02060603020205020403" pitchFamily="18" charset="0"/>
-              </a:rPr>
-              <a:t>BUSINESS UNDERSTANDING; PROBLEM STATEMENT</a:t>
+              <a:rPr lang="en-US" b="1" u="sng" dirty="0"/>
+              <a:t>INTRODUCTION</a:t>
             </a:r>
           </a:p>
         </p:txBody>
@@ -13799,7 +14678,7 @@
           <p:cNvPr id="3" name="Content Placeholder 2">
             <a:extLst>
               <a:ext uri="{FF2B5EF4-FFF2-40B4-BE49-F238E27FC236}">
-                <a16:creationId xmlns:a16="http://schemas.microsoft.com/office/drawing/2014/main" id="{143F5361-68C0-4BF5-80C8-F1E7BF92B2DB}"/>
+                <a16:creationId xmlns:a16="http://schemas.microsoft.com/office/drawing/2014/main" id="{7D91904D-7A33-E9C4-FF9A-8D7AD04668AF}"/>
               </a:ext>
             </a:extLst>
           </p:cNvPr>
@@ -13812,77 +14691,54 @@
         </p:nvSpPr>
         <p:spPr>
           <a:xfrm>
-            <a:off x="1141412" y="833718"/>
-            <a:ext cx="9905999" cy="4957483"/>
+            <a:off x="1141412" y="898358"/>
+            <a:ext cx="9905999" cy="4892843"/>
           </a:xfrm>
         </p:spPr>
         <p:txBody>
           <a:bodyPr>
-            <a:normAutofit fontScale="92500" lnSpcReduction="10000"/>
+            <a:normAutofit fontScale="92500" lnSpcReduction="20000"/>
           </a:bodyPr>
           <a:lstStyle/>
           <a:p>
             <a:r>
-              <a:rPr lang="en-US" dirty="0">
-                <a:latin typeface="Tahoma" panose="020B0604030504040204" pitchFamily="34" charset="0"/>
-                <a:ea typeface="Tahoma" panose="020B0604030504040204" pitchFamily="34" charset="0"/>
-                <a:cs typeface="Tahoma" panose="020B0604030504040204" pitchFamily="34" charset="0"/>
-              </a:rPr>
-              <a:t>BACKGROUND</a:t>
-            </a:r>
-          </a:p>
-          <a:p>
-            <a:pPr marL="457200" lvl="1" indent="0">
-              <a:buNone/>
+              <a:rPr lang="en-US" dirty="0"/>
+              <a:t>This project delivers an integrated mental health prediction and risk assessment tool, combining natural language processing for symptom-based disorder identification with machine learning for lifestyle-based risk evaluation. The system is designed for use by individuals, clinicians, and mental health practitioners, providing early detection, risk scoring, and actionable recommendations. The platform supports two complementary functionalities:</a:t>
+            </a:r>
+          </a:p>
+          <a:p>
+            <a:pPr marL="914400" lvl="1" indent="-457200">
+              <a:buAutoNum type="arabicPeriod"/>
             </a:pPr>
             <a:r>
               <a:rPr lang="en-US" dirty="0"/>
-              <a:t>Mental health significantly impacts daily life, yet many people—especially in low- and middle-income regions—face barriers to care, including stigma and lack of access. With over 1 in 8 people globally affected by mental health disorders, there is a pressing need for early and accessible support. AI can help fill this gap by detecting emotional distress through text, offering supportive feedback, and encouraging self-reflection. These tools not only aid individuals but also assist therapists by tracking emotional trends and enhancing patient care, making AI a valuable partner in mental health support.</a:t>
-            </a:r>
-            <a:endParaRPr lang="en-US" dirty="0">
-              <a:latin typeface="Tahoma" panose="020B0604030504040204" pitchFamily="34" charset="0"/>
-              <a:ea typeface="Tahoma" panose="020B0604030504040204" pitchFamily="34" charset="0"/>
-              <a:cs typeface="Tahoma" panose="020B0604030504040204" pitchFamily="34" charset="0"/>
-            </a:endParaRPr>
-          </a:p>
-          <a:p>
-            <a:r>
-              <a:rPr lang="en-US" dirty="0">
-                <a:latin typeface="Tahoma" panose="020B0604030504040204" pitchFamily="34" charset="0"/>
-                <a:ea typeface="Tahoma" panose="020B0604030504040204" pitchFamily="34" charset="0"/>
-                <a:cs typeface="Tahoma" panose="020B0604030504040204" pitchFamily="34" charset="0"/>
-              </a:rPr>
-              <a:t>PROBLEM STATEMENT</a:t>
-            </a:r>
-          </a:p>
-          <a:p>
-            <a:pPr marL="457200" lvl="1" indent="0">
-              <a:buNone/>
+              <a:t>Signs-Based Disorder Prediction – Users provide textual descriptions of symptoms, which are transformed into vector embeddings and classified into likely mental disorders. The model then returns relevant self-care and professional recommendations. </a:t>
+            </a:r>
+          </a:p>
+          <a:p>
+            <a:pPr marL="914400" lvl="1" indent="-457200">
+              <a:buAutoNum type="arabicPeriod"/>
             </a:pPr>
             <a:r>
               <a:rPr lang="en-US" dirty="0"/>
-              <a:t>Many people struggle with mental health issues but face barriers like cost, stigma, and limited access to therapists. Emotional distress often goes unaddressed, and even those in care lack tools for tracking emotions between sessions. There’s a growing need for accessible, private tools that support self-reflection and provide valuable insights to therapists.</a:t>
-            </a:r>
-            <a:endParaRPr lang="en-US" dirty="0">
-              <a:latin typeface="Tahoma" panose="020B0604030504040204" pitchFamily="34" charset="0"/>
-              <a:ea typeface="Tahoma" panose="020B0604030504040204" pitchFamily="34" charset="0"/>
-              <a:cs typeface="Tahoma" panose="020B0604030504040204" pitchFamily="34" charset="0"/>
-            </a:endParaRPr>
-          </a:p>
-          <a:p>
-            <a:pPr lvl="1"/>
-            <a:endParaRPr lang="en-US" dirty="0">
-              <a:latin typeface="Tahoma" panose="020B0604030504040204" pitchFamily="34" charset="0"/>
-              <a:ea typeface="Tahoma" panose="020B0604030504040204" pitchFamily="34" charset="0"/>
-              <a:cs typeface="Tahoma" panose="020B0604030504040204" pitchFamily="34" charset="0"/>
-            </a:endParaRPr>
+              <a:t>Lifestyle-Based Risk Assessment – Users input structured lifestyle and demographic data, and the model predicts both the likelihood and severity of mental health risk.</a:t>
+            </a:r>
+          </a:p>
+          <a:p>
+            <a:r>
+              <a:rPr lang="en-US" dirty="0"/>
+              <a:t>By combining these approaches, the application aims to provide holistic mental health evaluation, increasing awareness, promoting early intervention, and supporting informed decision-making.</a:t>
+            </a:r>
+          </a:p>
+          <a:p>
+            <a:endParaRPr lang="en-US" dirty="0"/>
           </a:p>
         </p:txBody>
       </p:sp>
     </p:spTree>
     <p:extLst>
       <p:ext uri="{BB962C8B-B14F-4D97-AF65-F5344CB8AC3E}">
-        <p14:creationId xmlns:p14="http://schemas.microsoft.com/office/powerpoint/2010/main" val="2172179498"/>
+        <p14:creationId xmlns:p14="http://schemas.microsoft.com/office/powerpoint/2010/main" val="2323005922"/>
       </p:ext>
     </p:extLst>
   </p:cSld>
@@ -13928,6 +14784,158 @@
         <p:spPr>
           <a:xfrm>
             <a:off x="1141413" y="0"/>
+            <a:ext cx="9905998" cy="1201271"/>
+          </a:xfrm>
+        </p:spPr>
+        <p:txBody>
+          <a:bodyPr>
+            <a:normAutofit/>
+          </a:bodyPr>
+          <a:lstStyle/>
+          <a:p>
+            <a:r>
+              <a:rPr lang="en-US" sz="2800" b="1" u="sng" dirty="0">
+                <a:latin typeface="Rockwell" panose="02060603020205020403" pitchFamily="18" charset="0"/>
+              </a:rPr>
+              <a:t>BUSINESS UNDERSTANDING; PROBLEM STATEMENT</a:t>
+            </a:r>
+          </a:p>
+        </p:txBody>
+      </p:sp>
+      <p:sp>
+        <p:nvSpPr>
+          <p:cNvPr id="3" name="Content Placeholder 2">
+            <a:extLst>
+              <a:ext uri="{FF2B5EF4-FFF2-40B4-BE49-F238E27FC236}">
+                <a16:creationId xmlns:a16="http://schemas.microsoft.com/office/drawing/2014/main" id="{143F5361-68C0-4BF5-80C8-F1E7BF92B2DB}"/>
+              </a:ext>
+            </a:extLst>
+          </p:cNvPr>
+          <p:cNvSpPr>
+            <a:spLocks noGrp="1"/>
+          </p:cNvSpPr>
+          <p:nvPr>
+            <p:ph idx="1"/>
+          </p:nvPr>
+        </p:nvSpPr>
+        <p:spPr>
+          <a:xfrm>
+            <a:off x="1141412" y="833718"/>
+            <a:ext cx="9905999" cy="4957483"/>
+          </a:xfrm>
+        </p:spPr>
+        <p:txBody>
+          <a:bodyPr>
+            <a:normAutofit fontScale="92500" lnSpcReduction="10000"/>
+          </a:bodyPr>
+          <a:lstStyle/>
+          <a:p>
+            <a:r>
+              <a:rPr lang="en-US" dirty="0">
+                <a:latin typeface="Tahoma" panose="020B0604030504040204" pitchFamily="34" charset="0"/>
+                <a:ea typeface="Tahoma" panose="020B0604030504040204" pitchFamily="34" charset="0"/>
+                <a:cs typeface="Tahoma" panose="020B0604030504040204" pitchFamily="34" charset="0"/>
+              </a:rPr>
+              <a:t>BACKGROUND</a:t>
+            </a:r>
+          </a:p>
+          <a:p>
+            <a:pPr marL="457200" lvl="1" indent="0">
+              <a:buNone/>
+            </a:pPr>
+            <a:r>
+              <a:rPr lang="en-US" dirty="0"/>
+              <a:t>Mental health significantly impacts daily life, yet many people—especially in low- and middle-income regions—face barriers to care, including stigma and lack of access. With over 1 in 8 people globally affected by mental health disorders, there is a pressing need for early and accessible support. AI can help fill this gap by detecting emotional distress through text, offering supportive feedback, and encouraging self-reflection. These tools not only aid individuals but also assist therapists by tracking emotional trends and enhancing patient care, making AI a valuable partner in mental health support.</a:t>
+            </a:r>
+            <a:endParaRPr lang="en-US" dirty="0">
+              <a:latin typeface="Tahoma" panose="020B0604030504040204" pitchFamily="34" charset="0"/>
+              <a:ea typeface="Tahoma" panose="020B0604030504040204" pitchFamily="34" charset="0"/>
+              <a:cs typeface="Tahoma" panose="020B0604030504040204" pitchFamily="34" charset="0"/>
+            </a:endParaRPr>
+          </a:p>
+          <a:p>
+            <a:r>
+              <a:rPr lang="en-US" dirty="0">
+                <a:latin typeface="Tahoma" panose="020B0604030504040204" pitchFamily="34" charset="0"/>
+                <a:ea typeface="Tahoma" panose="020B0604030504040204" pitchFamily="34" charset="0"/>
+                <a:cs typeface="Tahoma" panose="020B0604030504040204" pitchFamily="34" charset="0"/>
+              </a:rPr>
+              <a:t>PROBLEM STATEMENT</a:t>
+            </a:r>
+          </a:p>
+          <a:p>
+            <a:pPr marL="457200" lvl="1" indent="0">
+              <a:buNone/>
+            </a:pPr>
+            <a:r>
+              <a:rPr lang="en-US" dirty="0"/>
+              <a:t>Many people struggle with mental health issues but face barriers like cost, stigma, and limited access to therapists. Emotional distress often goes unaddressed, and even those in care lack tools for tracking emotions between sessions. There’s a growing need for accessible, private tools that support self-reflection and provide valuable insights to therapists.</a:t>
+            </a:r>
+            <a:endParaRPr lang="en-US" dirty="0">
+              <a:latin typeface="Tahoma" panose="020B0604030504040204" pitchFamily="34" charset="0"/>
+              <a:ea typeface="Tahoma" panose="020B0604030504040204" pitchFamily="34" charset="0"/>
+              <a:cs typeface="Tahoma" panose="020B0604030504040204" pitchFamily="34" charset="0"/>
+            </a:endParaRPr>
+          </a:p>
+          <a:p>
+            <a:pPr lvl="1"/>
+            <a:endParaRPr lang="en-US" dirty="0">
+              <a:latin typeface="Tahoma" panose="020B0604030504040204" pitchFamily="34" charset="0"/>
+              <a:ea typeface="Tahoma" panose="020B0604030504040204" pitchFamily="34" charset="0"/>
+              <a:cs typeface="Tahoma" panose="020B0604030504040204" pitchFamily="34" charset="0"/>
+            </a:endParaRPr>
+          </a:p>
+        </p:txBody>
+      </p:sp>
+    </p:spTree>
+    <p:extLst>
+      <p:ext uri="{BB962C8B-B14F-4D97-AF65-F5344CB8AC3E}">
+        <p14:creationId xmlns:p14="http://schemas.microsoft.com/office/powerpoint/2010/main" val="2172179498"/>
+      </p:ext>
+    </p:extLst>
+  </p:cSld>
+  <p:clrMapOvr>
+    <a:masterClrMapping/>
+  </p:clrMapOvr>
+</p:sld>
+</file>
+
+<file path=ppt/slides/slide4.xml><?xml version="1.0" encoding="utf-8"?>
+<p:sld xmlns:a="http://schemas.openxmlformats.org/drawingml/2006/main" xmlns:r="http://schemas.openxmlformats.org/officeDocument/2006/relationships" xmlns:p="http://schemas.openxmlformats.org/presentationml/2006/main">
+  <p:cSld>
+    <p:spTree>
+      <p:nvGrpSpPr>
+        <p:cNvPr id="1" name=""/>
+        <p:cNvGrpSpPr/>
+        <p:nvPr/>
+      </p:nvGrpSpPr>
+      <p:grpSpPr>
+        <a:xfrm>
+          <a:off x="0" y="0"/>
+          <a:ext cx="0" cy="0"/>
+          <a:chOff x="0" y="0"/>
+          <a:chExt cx="0" cy="0"/>
+        </a:xfrm>
+      </p:grpSpPr>
+      <p:sp>
+        <p:nvSpPr>
+          <p:cNvPr id="2" name="Title 1">
+            <a:extLst>
+              <a:ext uri="{FF2B5EF4-FFF2-40B4-BE49-F238E27FC236}">
+                <a16:creationId xmlns:a16="http://schemas.microsoft.com/office/drawing/2014/main" id="{34DB6CE4-2B13-4715-B5B2-615A55922CA1}"/>
+              </a:ext>
+            </a:extLst>
+          </p:cNvPr>
+          <p:cNvSpPr>
+            <a:spLocks noGrp="1"/>
+          </p:cNvSpPr>
+          <p:nvPr>
+            <p:ph type="title"/>
+          </p:nvPr>
+        </p:nvSpPr>
+        <p:spPr>
+          <a:xfrm>
+            <a:off x="1141413" y="0"/>
             <a:ext cx="9905998" cy="1347537"/>
           </a:xfrm>
         </p:spPr>
@@ -13938,7 +14946,7 @@
           <a:lstStyle/>
           <a:p>
             <a:r>
-              <a:rPr lang="en-US" b="1" u="sng" dirty="0">
+              <a:rPr lang="en-US" sz="3200" b="1" u="sng" dirty="0">
                 <a:latin typeface="Rockwell" panose="02060603020205020403" pitchFamily="18" charset="0"/>
               </a:rPr>
               <a:t>PROJECT DESCRIPTION; OBJECTIVES</a:t>
@@ -14263,7 +15271,7 @@
 </p:sld>
 </file>
 
-<file path=ppt/slides/slide4.xml><?xml version="1.0" encoding="utf-8"?>
+<file path=ppt/slides/slide5.xml><?xml version="1.0" encoding="utf-8"?>
 <p:sld xmlns:a="http://schemas.openxmlformats.org/drawingml/2006/main" xmlns:r="http://schemas.openxmlformats.org/officeDocument/2006/relationships" xmlns:p="http://schemas.openxmlformats.org/presentationml/2006/main">
   <p:cSld>
     <p:spTree>
@@ -14309,12 +15317,12 @@
           <a:lstStyle/>
           <a:p>
             <a:r>
-              <a:rPr lang="en-US" b="1" u="sng" dirty="0">
+              <a:rPr lang="en-US" sz="3200" b="1" u="sng" dirty="0">
                 <a:latin typeface="Rockwell" panose="02060603020205020403" pitchFamily="18" charset="0"/>
               </a:rPr>
               <a:t>PROJECT DESCRIPTION; OBJECTIVES</a:t>
             </a:r>
-            <a:endParaRPr lang="en-US" dirty="0">
+            <a:endParaRPr lang="en-US" sz="3200" dirty="0">
               <a:latin typeface="Rockwell" panose="02060603020205020403" pitchFamily="18" charset="0"/>
             </a:endParaRPr>
           </a:p>
@@ -14466,7 +15474,7 @@
 </p:sld>
 </file>
 
-<file path=ppt/slides/slide5.xml><?xml version="1.0" encoding="utf-8"?>
+<file path=ppt/slides/slide6.xml><?xml version="1.0" encoding="utf-8"?>
 <p:sld xmlns:a="http://schemas.openxmlformats.org/drawingml/2006/main" xmlns:r="http://schemas.openxmlformats.org/officeDocument/2006/relationships" xmlns:p="http://schemas.openxmlformats.org/presentationml/2006/main">
   <p:cSld>
     <p:spTree>
@@ -14625,7 +15633,7 @@
 </p:sld>
 </file>
 
-<file path=ppt/slides/slide6.xml><?xml version="1.0" encoding="utf-8"?>
+<file path=ppt/slides/slide7.xml><?xml version="1.0" encoding="utf-8"?>
 <p:sld xmlns:a="http://schemas.openxmlformats.org/drawingml/2006/main" xmlns:r="http://schemas.openxmlformats.org/officeDocument/2006/relationships" xmlns:p="http://schemas.openxmlformats.org/presentationml/2006/main">
   <p:cSld>
     <p:spTree>
@@ -14706,7 +15714,7 @@
               <a:buAutoNum type="arabicPeriod"/>
             </a:pPr>
             <a:r>
-              <a:rPr lang="en-US" dirty="0"/>
+              <a:rPr lang="en-US" b="1" dirty="0"/>
               <a:t>Mental health content</a:t>
             </a:r>
           </a:p>
@@ -14731,7 +15739,7 @@
               <a:t>Processed using </a:t>
             </a:r>
             <a:r>
-              <a:rPr lang="en-US" b="1" dirty="0" err="1"/>
+              <a:rPr lang="en-US" b="1" dirty="0"/>
               <a:t>SentenceBERT</a:t>
             </a:r>
             <a:r>
@@ -14745,7 +15753,7 @@
               <a:buAutoNum type="arabicPeriod"/>
             </a:pPr>
             <a:r>
-              <a:rPr lang="en-US" dirty="0"/>
+              <a:rPr lang="en-US" b="1" dirty="0"/>
               <a:t>Demographic and behavioral data</a:t>
             </a:r>
           </a:p>
@@ -14782,7 +15790,7 @@
               <a:t>Used to train the </a:t>
             </a:r>
             <a:r>
-              <a:rPr lang="en-US" b="1" dirty="0" err="1"/>
+              <a:rPr lang="en-US" b="1" dirty="0"/>
               <a:t>CatBoost</a:t>
             </a:r>
             <a:r>
@@ -14924,7 +15932,7 @@
 </p:sld>
 </file>
 
-<file path=ppt/slides/slide7.xml><?xml version="1.0" encoding="utf-8"?>
+<file path=ppt/slides/slide8.xml><?xml version="1.0" encoding="utf-8"?>
 <p:sld xmlns:a="http://schemas.openxmlformats.org/drawingml/2006/main" xmlns:r="http://schemas.openxmlformats.org/officeDocument/2006/relationships" xmlns:p="http://schemas.openxmlformats.org/presentationml/2006/main">
   <p:cSld>
     <p:spTree>
@@ -15002,14 +16010,14 @@
           <a:p>
             <a:r>
               <a:rPr lang="en-US" dirty="0"/>
-              <a:t>Before continuing to modeling we tried some EDA to try uncover patterns in the data. And we found;</a:t>
+              <a:t>Before continuing to modeling, we tried some EDA to uncover data patterns. And we found;</a:t>
             </a:r>
           </a:p>
           <a:p>
             <a:pPr lvl="1"/>
             <a:r>
               <a:rPr lang="en-US" dirty="0"/>
-              <a:t>Majority of users are aged between 20 and 35, showing mental health engagement is stronger among young adults.</a:t>
+              <a:t> The majority of users are aged between 20 and 35, showing mental health engagement is stronger among young adults.</a:t>
             </a:r>
           </a:p>
           <a:p>
@@ -15090,7 +16098,7 @@
 </p:sld>
 </file>
 
-<file path=ppt/slides/slide8.xml><?xml version="1.0" encoding="utf-8"?>
+<file path=ppt/slides/slide9.xml><?xml version="1.0" encoding="utf-8"?>
 <p:sld xmlns:a="http://schemas.openxmlformats.org/drawingml/2006/main" xmlns:r="http://schemas.openxmlformats.org/officeDocument/2006/relationships" xmlns:p="http://schemas.openxmlformats.org/presentationml/2006/main">
   <p:cSld>
     <p:spTree>
@@ -15173,7 +16181,7 @@
               <a:buAutoNum type="arabicPeriod"/>
             </a:pPr>
             <a:r>
-              <a:rPr lang="en-US" dirty="0"/>
+              <a:rPr lang="en-US" b="1" dirty="0"/>
               <a:t>Text-based modeling</a:t>
             </a:r>
           </a:p>
@@ -15184,7 +16192,7 @@
               <a:t>Used </a:t>
             </a:r>
             <a:r>
-              <a:rPr lang="en-US" b="1" dirty="0" err="1"/>
+              <a:rPr lang="en-US" b="1" dirty="0"/>
               <a:t>SentenceBERT</a:t>
             </a:r>
             <a:r>
@@ -15253,27 +16261,23 @@
               <a:buAutoNum type="arabicPeriod"/>
             </a:pPr>
             <a:r>
+              <a:rPr lang="en-US" b="1" dirty="0"/>
+              <a:t>Structured data modeling</a:t>
+            </a:r>
+          </a:p>
+          <a:p>
+            <a:pPr lvl="1"/>
+            <a:r>
               <a:rPr lang="en-US" dirty="0"/>
-              <a:t>Structured data modeling</a:t>
-            </a:r>
-          </a:p>
-          <a:p>
-            <a:pPr lvl="1"/>
+              <a:t>Used a stacked model of Gradient Boosting and </a:t>
+            </a:r>
+            <a:r>
+              <a:rPr lang="en-US" dirty="0" err="1"/>
+              <a:t>CatBoost</a:t>
+            </a:r>
             <a:r>
               <a:rPr lang="en-US" dirty="0"/>
-              <a:t>Used a </a:t>
-            </a:r>
-            <a:r>
-              <a:rPr lang="en-US" b="1" dirty="0" err="1"/>
-              <a:t>CatBoost</a:t>
-            </a:r>
-            <a:r>
-              <a:rPr lang="en-US" b="1" dirty="0"/>
-              <a:t> Classifier</a:t>
-            </a:r>
-            <a:r>
-              <a:rPr lang="en-US" dirty="0"/>
-              <a:t> trained on 13 behavioral and demographic feature</a:t>
+              <a:t> Classifier to train 13 behavioral and demographic features</a:t>
             </a:r>
           </a:p>
           <a:p>
@@ -15304,236 +16308,6 @@
     <p:extLst>
       <p:ext uri="{BB962C8B-B14F-4D97-AF65-F5344CB8AC3E}">
         <p14:creationId xmlns:p14="http://schemas.microsoft.com/office/powerpoint/2010/main" val="2497466198"/>
-      </p:ext>
-    </p:extLst>
-  </p:cSld>
-  <p:clrMapOvr>
-    <a:masterClrMapping/>
-  </p:clrMapOvr>
-</p:sld>
-</file>
-
-<file path=ppt/slides/slide9.xml><?xml version="1.0" encoding="utf-8"?>
-<p:sld xmlns:a="http://schemas.openxmlformats.org/drawingml/2006/main" xmlns:r="http://schemas.openxmlformats.org/officeDocument/2006/relationships" xmlns:p="http://schemas.openxmlformats.org/presentationml/2006/main">
-  <p:cSld>
-    <p:spTree>
-      <p:nvGrpSpPr>
-        <p:cNvPr id="1" name=""/>
-        <p:cNvGrpSpPr/>
-        <p:nvPr/>
-      </p:nvGrpSpPr>
-      <p:grpSpPr>
-        <a:xfrm>
-          <a:off x="0" y="0"/>
-          <a:ext cx="0" cy="0"/>
-          <a:chOff x="0" y="0"/>
-          <a:chExt cx="0" cy="0"/>
-        </a:xfrm>
-      </p:grpSpPr>
-      <p:sp>
-        <p:nvSpPr>
-          <p:cNvPr id="2" name="Title 1">
-            <a:extLst>
-              <a:ext uri="{FF2B5EF4-FFF2-40B4-BE49-F238E27FC236}">
-                <a16:creationId xmlns:a16="http://schemas.microsoft.com/office/drawing/2014/main" id="{9FC2FFC0-03FB-BF0B-9FDA-F0F111D43D3F}"/>
-              </a:ext>
-            </a:extLst>
-          </p:cNvPr>
-          <p:cNvSpPr>
-            <a:spLocks noGrp="1"/>
-          </p:cNvSpPr>
-          <p:nvPr>
-            <p:ph type="title"/>
-          </p:nvPr>
-        </p:nvSpPr>
-        <p:spPr>
-          <a:xfrm>
-            <a:off x="1141413" y="0"/>
-            <a:ext cx="9905998" cy="1066799"/>
-          </a:xfrm>
-        </p:spPr>
-        <p:txBody>
-          <a:bodyPr/>
-          <a:lstStyle/>
-          <a:p>
-            <a:r>
-              <a:rPr lang="en-US" b="1" u="sng" dirty="0"/>
-              <a:t>MODEL INTERPRETABILITY AND EVALUATION</a:t>
-            </a:r>
-          </a:p>
-        </p:txBody>
-      </p:sp>
-      <p:sp>
-        <p:nvSpPr>
-          <p:cNvPr id="3" name="Content Placeholder 2">
-            <a:extLst>
-              <a:ext uri="{FF2B5EF4-FFF2-40B4-BE49-F238E27FC236}">
-                <a16:creationId xmlns:a16="http://schemas.microsoft.com/office/drawing/2014/main" id="{917A464B-0220-F4AA-19D9-4A314A2A0154}"/>
-              </a:ext>
-            </a:extLst>
-          </p:cNvPr>
-          <p:cNvSpPr>
-            <a:spLocks noGrp="1"/>
-          </p:cNvSpPr>
-          <p:nvPr>
-            <p:ph idx="1"/>
-          </p:nvPr>
-        </p:nvSpPr>
-        <p:spPr>
-          <a:xfrm>
-            <a:off x="1141412" y="898358"/>
-            <a:ext cx="9905999" cy="5245768"/>
-          </a:xfrm>
-        </p:spPr>
-        <p:txBody>
-          <a:bodyPr>
-            <a:normAutofit lnSpcReduction="10000"/>
-          </a:bodyPr>
-          <a:lstStyle/>
-          <a:p>
-            <a:pPr marL="457200" indent="-457200">
-              <a:buFont typeface="+mj-lt"/>
-              <a:buAutoNum type="arabicPeriod"/>
-            </a:pPr>
-            <a:r>
-              <a:rPr lang="en-US" b="1" dirty="0"/>
-              <a:t>Text-based model </a:t>
-            </a:r>
-            <a:r>
-              <a:rPr lang="en-US" dirty="0"/>
-              <a:t>(</a:t>
-            </a:r>
-            <a:r>
-              <a:rPr lang="en-US" dirty="0" err="1"/>
-              <a:t>sentenceBERT</a:t>
-            </a:r>
-            <a:r>
-              <a:rPr lang="en-US" dirty="0"/>
-              <a:t> + multi-label classifier)</a:t>
-            </a:r>
-          </a:p>
-          <a:p>
-            <a:pPr lvl="1"/>
-            <a:r>
-              <a:rPr lang="en-US" b="1" dirty="0"/>
-              <a:t>Goal</a:t>
-            </a:r>
-            <a:r>
-              <a:rPr lang="en-US" dirty="0"/>
-              <a:t>: Detect mental health conditions (e.g., anxiety, depression, burnout) from symptom descriptions</a:t>
-            </a:r>
-          </a:p>
-          <a:p>
-            <a:pPr lvl="1"/>
-            <a:r>
-              <a:rPr lang="en-US" b="1" dirty="0"/>
-              <a:t>Evaluation Metrics</a:t>
-            </a:r>
-            <a:r>
-              <a:rPr lang="en-US" dirty="0"/>
-              <a:t>:</a:t>
-            </a:r>
-          </a:p>
-          <a:p>
-            <a:pPr lvl="3"/>
-            <a:r>
-              <a:rPr lang="en-US" b="1" dirty="0"/>
-              <a:t>Hamming Loss</a:t>
-            </a:r>
-            <a:r>
-              <a:rPr lang="en-US" dirty="0"/>
-              <a:t>: 0.14</a:t>
-            </a:r>
-          </a:p>
-          <a:p>
-            <a:pPr lvl="3"/>
-            <a:r>
-              <a:rPr lang="en-US" b="1" dirty="0"/>
-              <a:t>Subset Accuracy</a:t>
-            </a:r>
-            <a:r>
-              <a:rPr lang="en-US" dirty="0"/>
-              <a:t>: 76%</a:t>
-            </a:r>
-          </a:p>
-          <a:p>
-            <a:pPr lvl="3"/>
-            <a:r>
-              <a:rPr lang="en-US" b="1" dirty="0"/>
-              <a:t>Macro F1-score</a:t>
-            </a:r>
-            <a:r>
-              <a:rPr lang="en-US" dirty="0"/>
-              <a:t>: 0.81</a:t>
-            </a:r>
-          </a:p>
-          <a:p>
-            <a:pPr marL="457200" indent="-457200">
-              <a:buFont typeface="+mj-lt"/>
-              <a:buAutoNum type="arabicPeriod"/>
-            </a:pPr>
-            <a:r>
-              <a:rPr lang="en-US" b="1" dirty="0"/>
-              <a:t>Structured data model </a:t>
-            </a:r>
-            <a:r>
-              <a:rPr lang="en-US" dirty="0"/>
-              <a:t>(</a:t>
-            </a:r>
-            <a:r>
-              <a:rPr lang="en-US" dirty="0" err="1"/>
-              <a:t>CatBoostClassifier</a:t>
-            </a:r>
-            <a:r>
-              <a:rPr lang="en-US" dirty="0"/>
-              <a:t>)</a:t>
-            </a:r>
-          </a:p>
-          <a:p>
-            <a:pPr lvl="1"/>
-            <a:r>
-              <a:rPr lang="en-US" b="1" dirty="0"/>
-              <a:t>Goal</a:t>
-            </a:r>
-            <a:r>
-              <a:rPr lang="en-US" dirty="0"/>
-              <a:t>: Predict mental health conditions &amp; severity from lifestyle features</a:t>
-            </a:r>
-          </a:p>
-          <a:p>
-            <a:pPr lvl="1"/>
-            <a:r>
-              <a:rPr lang="en-US" dirty="0"/>
-              <a:t>Evaluation metrics:</a:t>
-            </a:r>
-          </a:p>
-          <a:p>
-            <a:pPr lvl="2"/>
-            <a:r>
-              <a:rPr lang="en-US" dirty="0"/>
-              <a:t>Accuracy: 83%</a:t>
-            </a:r>
-          </a:p>
-          <a:p>
-            <a:pPr lvl="2"/>
-            <a:r>
-              <a:rPr lang="en-US" dirty="0"/>
-              <a:t>Marco F1-score: 0.78</a:t>
-            </a:r>
-          </a:p>
-          <a:p>
-            <a:pPr lvl="2"/>
-            <a:r>
-              <a:rPr lang="en-US" dirty="0"/>
-              <a:t>Weighted f1-score: 0.82</a:t>
-            </a:r>
-          </a:p>
-        </p:txBody>
-      </p:sp>
-    </p:spTree>
-    <p:extLst>
-      <p:ext uri="{BB962C8B-B14F-4D97-AF65-F5344CB8AC3E}">
-        <p14:creationId xmlns:p14="http://schemas.microsoft.com/office/powerpoint/2010/main" val="4238847071"/>
       </p:ext>
     </p:extLst>
   </p:cSld>
@@ -16385,23 +17159,6 @@
 </file>
 
 <file path=customXml/item1.xml><?xml version="1.0" encoding="utf-8"?>
-<p:properties xmlns:p="http://schemas.microsoft.com/office/2006/metadata/properties" xmlns:xsi="http://www.w3.org/2001/XMLSchema-instance" xmlns:pc="http://schemas.microsoft.com/office/infopath/2007/PartnerControls">
-  <documentManagement>
-    <MediaServiceKeyPoints xmlns="71af3243-3dd4-4a8d-8c0d-dd76da1f02a5" xsi:nil="true"/>
-  </documentManagement>
-</p:properties>
-</file>
-
-<file path=customXml/item2.xml><?xml version="1.0" encoding="utf-8"?>
-<?mso-contentType ?>
-<FormTemplates xmlns="http://schemas.microsoft.com/sharepoint/v3/contenttype/forms">
-  <Display>DocumentLibraryForm</Display>
-  <Edit>DocumentLibraryForm</Edit>
-  <New>DocumentLibraryForm</New>
-</FormTemplates>
-</file>
-
-<file path=customXml/item3.xml><?xml version="1.0" encoding="utf-8"?>
 <ct:contentTypeSchema xmlns:ct="http://schemas.microsoft.com/office/2006/metadata/contentType" xmlns:ma="http://schemas.microsoft.com/office/2006/metadata/properties/metaAttributes" ct:_="" ma:_="" ma:contentTypeName="Document" ma:contentTypeID="0x01010079F111ED35F8CC479449609E8A0923A6" ma:contentTypeVersion="11" ma:contentTypeDescription="Create a new document." ma:contentTypeScope="" ma:versionID="96291512c1ee715ab617f4c07df79fc1">
   <xsd:schema xmlns:xsd="http://www.w3.org/2001/XMLSchema" xmlns:xs="http://www.w3.org/2001/XMLSchema" xmlns:p="http://schemas.microsoft.com/office/2006/metadata/properties" xmlns:ns2="71af3243-3dd4-4a8d-8c0d-dd76da1f02a5" xmlns:ns3="16c05727-aa75-4e4a-9b5f-8a80a1165891" targetNamespace="http://schemas.microsoft.com/office/2006/metadata/properties" ma:root="true" ma:fieldsID="8256c27c40ca5c40ce1cf6c44f0205df" ns2:_="" ns3:_="">
     <xsd:import namespace="71af3243-3dd4-4a8d-8c0d-dd76da1f02a5"/>
@@ -16612,25 +17369,24 @@
 </ct:contentTypeSchema>
 </file>
 
-<file path=customXml/itemProps1.xml><?xml version="1.0" encoding="utf-8"?>
-<ds:datastoreItem xmlns:ds="http://schemas.openxmlformats.org/officeDocument/2006/customXml" ds:itemID="{E7866CFD-F94E-4AE5-ACEA-86FEC0F48A10}">
-  <ds:schemaRefs>
-    <ds:schemaRef ds:uri="http://schemas.microsoft.com/office/2006/metadata/properties"/>
-    <ds:schemaRef ds:uri="http://schemas.microsoft.com/office/infopath/2007/PartnerControls"/>
-    <ds:schemaRef ds:uri="71af3243-3dd4-4a8d-8c0d-dd76da1f02a5"/>
-  </ds:schemaRefs>
-</ds:datastoreItem>
+<file path=customXml/item2.xml><?xml version="1.0" encoding="utf-8"?>
+<p:properties xmlns:p="http://schemas.microsoft.com/office/2006/metadata/properties" xmlns:xsi="http://www.w3.org/2001/XMLSchema-instance" xmlns:pc="http://schemas.microsoft.com/office/infopath/2007/PartnerControls">
+  <documentManagement>
+    <MediaServiceKeyPoints xmlns="71af3243-3dd4-4a8d-8c0d-dd76da1f02a5" xsi:nil="true"/>
+  </documentManagement>
+</p:properties>
 </file>
 
-<file path=customXml/itemProps2.xml><?xml version="1.0" encoding="utf-8"?>
-<ds:datastoreItem xmlns:ds="http://schemas.openxmlformats.org/officeDocument/2006/customXml" ds:itemID="{B579702B-25C7-40D7-9E29-7686B11A9660}">
-  <ds:schemaRefs>
-    <ds:schemaRef ds:uri="http://schemas.microsoft.com/sharepoint/v3/contenttype/forms"/>
-  </ds:schemaRefs>
-</ds:datastoreItem>
+<file path=customXml/item3.xml><?xml version="1.0" encoding="utf-8"?>
+<?mso-contentType ?>
+<FormTemplates xmlns="http://schemas.microsoft.com/sharepoint/v3/contenttype/forms">
+  <Display>DocumentLibraryForm</Display>
+  <Edit>DocumentLibraryForm</Edit>
+  <New>DocumentLibraryForm</New>
+</FormTemplates>
 </file>
 
-<file path=customXml/itemProps3.xml><?xml version="1.0" encoding="utf-8"?>
+<file path=customXml/itemProps1.xml><?xml version="1.0" encoding="utf-8"?>
 <ds:datastoreItem xmlns:ds="http://schemas.openxmlformats.org/officeDocument/2006/customXml" ds:itemID="{A7C0B241-13E5-418D-8920-D23491E2D2C0}">
   <ds:schemaRefs>
     <ds:schemaRef ds:uri="http://schemas.microsoft.com/office/2006/metadata/contentType"/>
@@ -16647,4 +17403,22 @@
     <ds:schemaRef ds:uri="http://schemas.microsoft.com/internal/obd"/>
   </ds:schemaRefs>
 </ds:datastoreItem>
+</file>
+
+<file path=customXml/itemProps2.xml><?xml version="1.0" encoding="utf-8"?>
+<ds:datastoreItem xmlns:ds="http://schemas.openxmlformats.org/officeDocument/2006/customXml" ds:itemID="{E7866CFD-F94E-4AE5-ACEA-86FEC0F48A10}">
+  <ds:schemaRefs>
+    <ds:schemaRef ds:uri="http://schemas.microsoft.com/office/2006/metadata/properties"/>
+    <ds:schemaRef ds:uri="http://schemas.microsoft.com/office/infopath/2007/PartnerControls"/>
+    <ds:schemaRef ds:uri="71af3243-3dd4-4a8d-8c0d-dd76da1f02a5"/>
+  </ds:schemaRefs>
+</ds:datastoreItem>
+</file>
+
+<file path=customXml/itemProps3.xml><?xml version="1.0" encoding="utf-8"?>
+<ds:datastoreItem xmlns:ds="http://schemas.openxmlformats.org/officeDocument/2006/customXml" ds:itemID="{B579702B-25C7-40D7-9E29-7686B11A9660}">
+  <ds:schemaRefs>
+    <ds:schemaRef ds:uri="http://schemas.microsoft.com/sharepoint/v3/contenttype/forms"/>
+  </ds:schemaRefs>
+</ds:datastoreItem>
 </file>
</xml_diff>